<commit_message>
Fix R5/R6 slide titles in presentation template to match rebalanced roles
</commit_message>
<xml_diff>
--- a/assets/sprint-presentation-template.pptx
+++ b/assets/sprint-presentation-template.pptx
@@ -4633,7 +4633,7 @@
                 <a:ea typeface="Arial" pitchFamily="34" charset="-122"/>
                 <a:cs typeface="Arial" pitchFamily="34" charset="-120"/>
               </a:rPr>
-              <a:t>R5 — HUMAN SCORE LEAD ★ MOST IMPORTANT</a:t>
+              <a:t>R5 — HUMAN SCORE &amp; UI LEAD ★ MOST IMPORTANT</a:t>
             </a:r>
             <a:endParaRPr lang="en-US" sz="1100" dirty="0"/>
           </a:p>
@@ -4704,6 +4704,10 @@
             <a:prstDash val="solid"/>
           </a:ln>
         </p:spPr>
+        <p:txBody>
+          <a:bodyPr/>
+          <a:p/>
+        </p:txBody>
       </p:sp>
       <p:sp>
         <p:nvSpPr>
@@ -4804,6 +4808,10 @@
           </a:solidFill>
           <a:ln/>
         </p:spPr>
+        <p:txBody>
+          <a:bodyPr/>
+          <a:p/>
+        </p:txBody>
       </p:sp>
       <p:sp>
         <p:nvSpPr>
@@ -5026,7 +5034,7 @@
                 <a:ea typeface="Arial" pitchFamily="34" charset="-122"/>
                 <a:cs typeface="Arial" pitchFamily="34" charset="-120"/>
               </a:rPr>
-              <a:t>R6 — LLM, GITHUB &amp; UI OPERATOR</a:t>
+              <a:t>R6 — LLM &amp; GITHUB OPERATOR</a:t>
             </a:r>
             <a:endParaRPr lang="en-US" sz="1100" dirty="0"/>
           </a:p>
@@ -5065,7 +5073,7 @@
                 <a:ea typeface="Arial" pitchFamily="34" charset="-122"/>
                 <a:cs typeface="Arial" pitchFamily="34" charset="-120"/>
               </a:rPr>
-              <a:t>Model Comparison, Repo &amp; Interface</a:t>
+              <a:t>Model Comparison &amp; Repo</a:t>
             </a:r>
             <a:endParaRPr lang="en-US" sz="2600" dirty="0"/>
           </a:p>
@@ -5919,6 +5927,10 @@
             <a:prstDash val="solid"/>
           </a:ln>
         </p:spPr>
+        <p:txBody>
+          <a:bodyPr/>
+          <a:p/>
+        </p:txBody>
       </p:sp>
       <p:sp>
         <p:nvSpPr>

</xml_diff>

<commit_message>
Final role rebalance: R3 slide title + field updated to Technical & Economic
</commit_message>
<xml_diff>
--- a/assets/sprint-presentation-template.pptx
+++ b/assets/sprint-presentation-template.pptx
@@ -3055,7 +3055,7 @@
                 <a:ea typeface="Arial" pitchFamily="34" charset="-122"/>
                 <a:cs typeface="Arial" pitchFamily="34" charset="-120"/>
               </a:rPr>
-              <a:t>R3 — TECHNICAL ANALYST</a:t>
+              <a:t>R3 — TECHNICAL &amp; ECONOMIC ANALYST</a:t>
             </a:r>
             <a:endParaRPr lang="en-US" sz="1100" dirty="0"/>
           </a:p>
@@ -3126,6 +3126,10 @@
             <a:prstDash val="solid"/>
           </a:ln>
         </p:spPr>
+        <p:txBody>
+          <a:bodyPr/>
+          <a:p/>
+        </p:txBody>
       </p:sp>
       <p:sp>
         <p:nvSpPr>
@@ -3433,7 +3437,7 @@
                 <a:ea typeface="Arial" pitchFamily="34" charset="-122"/>
                 <a:cs typeface="Arial" pitchFamily="34" charset="-120"/>
               </a:rPr>
-              <a:t>VOLUME PATTERN</a:t>
+              <a:t>ECONOMIC SIGNAL</a:t>
             </a:r>
             <a:endParaRPr lang="en-US" sz="1000" dirty="0"/>
           </a:p>

</xml_diff>